<commit_message>
module8 deck: 12 slides (Δv currency, apsis rule, scoring); instructor guide beats rewritten
Detail in docs/CHANGELOG.md.
</commit_message>
<xml_diff>
--- a/slides/module1.pptx
+++ b/slides/module1.pptx
@@ -11,6 +11,7 @@
     <p:sldId id="259" r:id="rId11"/>
     <p:sldId id="260" r:id="rId12"/>
     <p:sldId id="261" r:id="rId13"/>
+    <p:sldId id="264" r:id="rId16"/>
     <p:sldId id="262" r:id="rId14"/>
     <p:sldId id="263" r:id="rId15"/>
   </p:sldIdLst>
@@ -8189,6 +8190,803 @@
                 <a:latin typeface="Arial"/>
               </a:rPr>
               <a:t>Open Worksheet 1 and keep the simulator beside it.</a:t>
+            </a:r>
+          </a:p>
+        </p:txBody>
+      </p:sp>
+    </p:spTree>
+  </p:cSld>
+  <p:clrMapOvr>
+    <a:masterClrMapping/>
+  </p:clrMapOvr>
+</p:sld>
+</file>
+
+<file path=ppt/slides/slide9.xml><?xml version="1.0" encoding="utf-8"?>
+<p:sld xmlns:a="http://schemas.openxmlformats.org/drawingml/2006/main" xmlns:p="http://schemas.openxmlformats.org/presentationml/2006/main" xmlns:r="http://schemas.openxmlformats.org/officeDocument/2006/relationships">
+  <p:cSld>
+    <p:bg>
+      <p:bgPr>
+        <a:solidFill>
+          <a:srgbClr val="050A14"/>
+        </a:solidFill>
+        <a:effectLst/>
+      </p:bgPr>
+    </p:bg>
+    <p:spTree>
+      <p:nvGrpSpPr>
+        <p:cNvPr id="1" name=""/>
+        <p:cNvGrpSpPr/>
+        <p:nvPr/>
+      </p:nvGrpSpPr>
+      <p:grpSpPr/>
+      <p:sp>
+        <p:nvSpPr>
+          <p:cNvPr id="2" name="TextBox 1"/>
+          <p:cNvSpPr txBox="1"/>
+          <p:nvPr/>
+        </p:nvSpPr>
+        <p:spPr>
+          <a:xfrm>
+            <a:off x="548640" y="384048"/>
+            <a:ext cx="8686800" cy="292608"/>
+          </a:xfrm>
+          <a:prstGeom prst="rect">
+            <a:avLst/>
+          </a:prstGeom>
+          <a:noFill/>
+        </p:spPr>
+        <p:txBody>
+          <a:bodyPr wrap="square" lIns="0" rIns="0" tIns="0" bIns="0">
+            <a:spAutoFit/>
+          </a:bodyPr>
+          <a:lstStyle/>
+          <a:p>
+            <a:pPr algn="l"/>
+            <a:r>
+              <a:rPr sz="1100" b="1" i="0">
+                <a:solidFill>
+                  <a:srgbClr val="FFCF4D"/>
+                </a:solidFill>
+                <a:latin typeface="Arial"/>
+              </a:rPr>
+              <a:t>MODULE 1 · ORBIT ACADEMY</a:t>
+            </a:r>
+          </a:p>
+        </p:txBody>
+      </p:sp>
+      <p:sp>
+        <p:nvSpPr>
+          <p:cNvPr id="3" name="TextBox 2"/>
+          <p:cNvSpPr txBox="1"/>
+          <p:nvPr/>
+        </p:nvSpPr>
+        <p:spPr>
+          <a:xfrm>
+            <a:off x="548640" y="676656"/>
+            <a:ext cx="10058400" cy="640080"/>
+          </a:xfrm>
+          <a:prstGeom prst="rect">
+            <a:avLst/>
+          </a:prstGeom>
+          <a:noFill/>
+        </p:spPr>
+        <p:txBody>
+          <a:bodyPr wrap="square" lIns="0" rIns="0" tIns="0" bIns="0">
+            <a:spAutoFit/>
+          </a:bodyPr>
+          <a:lstStyle/>
+          <a:p>
+            <a:pPr algn="l"/>
+            <a:r>
+              <a:rPr sz="2700" b="1" i="0">
+                <a:solidFill>
+                  <a:srgbClr val="5FD0FF"/>
+                </a:solidFill>
+                <a:latin typeface="Arial"/>
+              </a:rPr>
+              <a:t>Driving the simulator</a:t>
+            </a:r>
+          </a:p>
+        </p:txBody>
+      </p:sp>
+      <p:sp>
+        <p:nvSpPr>
+          <p:cNvPr id="4" name="Oval 3"/>
+          <p:cNvSpPr/>
+          <p:nvPr/>
+        </p:nvSpPr>
+        <p:spPr>
+          <a:xfrm>
+            <a:off x="10835640" y="484632"/>
+            <a:ext cx="914400" cy="347472"/>
+          </a:xfrm>
+          <a:prstGeom prst="ellipse">
+            <a:avLst/>
+          </a:prstGeom>
+          <a:noFill/>
+          <a:ln w="12700">
+            <a:solidFill>
+              <a:srgbClr val="2A4A74"/>
+            </a:solidFill>
+          </a:ln>
+          <a:effectLst/>
+        </p:spPr>
+        <p:style>
+          <a:lnRef idx="1">
+            <a:schemeClr val="accent1"/>
+          </a:lnRef>
+          <a:fillRef idx="3">
+            <a:schemeClr val="accent1"/>
+          </a:fillRef>
+          <a:effectRef idx="2">
+            <a:schemeClr val="accent1"/>
+          </a:effectRef>
+          <a:fontRef idx="minor">
+            <a:schemeClr val="lt1"/>
+          </a:fontRef>
+        </p:style>
+        <p:txBody>
+          <a:bodyPr rtlCol="0" anchor="ctr"/>
+          <a:lstStyle/>
+          <a:p>
+            <a:pPr algn="ctr"/>
+          </a:p>
+        </p:txBody>
+      </p:sp>
+      <p:sp>
+        <p:nvSpPr>
+          <p:cNvPr id="5" name="Oval 4"/>
+          <p:cNvSpPr/>
+          <p:nvPr/>
+        </p:nvSpPr>
+        <p:spPr>
+          <a:xfrm>
+            <a:off x="11708892" y="617219"/>
+            <a:ext cx="82296" cy="82296"/>
+          </a:xfrm>
+          <a:prstGeom prst="ellipse">
+            <a:avLst/>
+          </a:prstGeom>
+          <a:solidFill>
+            <a:srgbClr val="FFCF4D"/>
+          </a:solidFill>
+          <a:ln>
+            <a:noFill/>
+          </a:ln>
+          <a:effectLst/>
+        </p:spPr>
+        <p:style>
+          <a:lnRef idx="1">
+            <a:schemeClr val="accent1"/>
+          </a:lnRef>
+          <a:fillRef idx="3">
+            <a:schemeClr val="accent1"/>
+          </a:fillRef>
+          <a:effectRef idx="2">
+            <a:schemeClr val="accent1"/>
+          </a:effectRef>
+          <a:fontRef idx="minor">
+            <a:schemeClr val="lt1"/>
+          </a:fontRef>
+        </p:style>
+        <p:txBody>
+          <a:bodyPr rtlCol="0" anchor="ctr"/>
+          <a:lstStyle/>
+          <a:p>
+            <a:pPr algn="ctr"/>
+          </a:p>
+        </p:txBody>
+      </p:sp>
+      <p:sp>
+        <p:nvSpPr>
+          <p:cNvPr id="6" name="Rounded Rectangle 5"/>
+          <p:cNvSpPr/>
+          <p:nvPr/>
+        </p:nvSpPr>
+        <p:spPr>
+          <a:xfrm>
+            <a:off x="548640" y="1645920"/>
+            <a:ext cx="2834640" cy="960120"/>
+          </a:xfrm>
+          <a:prstGeom prst="roundRect">
+            <a:avLst>
+              <a:gd name="adj" fmla="val 7000"/>
+            </a:avLst>
+          </a:prstGeom>
+          <a:solidFill>
+            <a:srgbClr val="0A1830"/>
+          </a:solidFill>
+          <a:ln w="12700">
+            <a:solidFill>
+              <a:srgbClr val="1E3A5F"/>
+            </a:solidFill>
+          </a:ln>
+          <a:effectLst/>
+        </p:spPr>
+        <p:style>
+          <a:lnRef idx="1">
+            <a:schemeClr val="accent1"/>
+          </a:lnRef>
+          <a:fillRef idx="3">
+            <a:schemeClr val="accent1"/>
+          </a:fillRef>
+          <a:effectRef idx="2">
+            <a:schemeClr val="accent1"/>
+          </a:effectRef>
+          <a:fontRef idx="minor">
+            <a:schemeClr val="lt1"/>
+          </a:fontRef>
+        </p:style>
+        <p:txBody>
+          <a:bodyPr rtlCol="0" anchor="ctr"/>
+          <a:lstStyle/>
+          <a:p>
+            <a:pPr algn="ctr"/>
+          </a:p>
+        </p:txBody>
+      </p:sp>
+      <p:sp>
+        <p:nvSpPr>
+          <p:cNvPr id="7" name="TextBox 6"/>
+          <p:cNvSpPr txBox="1"/>
+          <p:nvPr/>
+        </p:nvSpPr>
+        <p:spPr>
+          <a:xfrm>
+            <a:off x="777240" y="1645920"/>
+            <a:ext cx="2377440" cy="960120"/>
+          </a:xfrm>
+          <a:prstGeom prst="rect">
+            <a:avLst/>
+          </a:prstGeom>
+          <a:noFill/>
+        </p:spPr>
+        <p:txBody>
+          <a:bodyPr wrap="square" lIns="0" rIns="0" tIns="0" bIns="0" anchor="ctr">
+            <a:spAutoFit/>
+          </a:bodyPr>
+          <a:lstStyle/>
+          <a:p>
+            <a:pPr algn="l">
+              <a:spcAft>
+                <a:spcPts val="300"/>
+              </a:spcAft>
+            </a:pPr>
+            <a:r>
+              <a:rPr sz="1500" b="1" i="0">
+                <a:solidFill>
+                  <a:srgbClr val="39D353"/>
+                </a:solidFill>
+                <a:latin typeface="Arial"/>
+              </a:rPr>
+              <a:t>🖱 MOUSE</a:t>
+            </a:r>
+          </a:p>
+          <a:p>
+            <a:pPr algn="l"/>
+            <a:r>
+              <a:rPr sz="1050" b="0" i="0">
+                <a:solidFill>
+                  <a:srgbClr val="7E93B8"/>
+                </a:solidFill>
+                <a:latin typeface="Arial"/>
+              </a:rPr>
+              <a:t>drag = pan · wheel = zoom · Shift-drag = rotate</a:t>
+            </a:r>
+          </a:p>
+        </p:txBody>
+      </p:sp>
+      <p:sp>
+        <p:nvSpPr>
+          <p:cNvPr id="9" name="Rounded Rectangle 8"/>
+          <p:cNvSpPr/>
+          <p:nvPr/>
+        </p:nvSpPr>
+        <p:spPr>
+          <a:xfrm>
+            <a:off x="3794759" y="1645920"/>
+            <a:ext cx="2834640" cy="960120"/>
+          </a:xfrm>
+          <a:prstGeom prst="roundRect">
+            <a:avLst>
+              <a:gd name="adj" fmla="val 7000"/>
+            </a:avLst>
+          </a:prstGeom>
+          <a:solidFill>
+            <a:srgbClr val="0A1830"/>
+          </a:solidFill>
+          <a:ln w="12700">
+            <a:solidFill>
+              <a:srgbClr val="1E3A5F"/>
+            </a:solidFill>
+          </a:ln>
+          <a:effectLst/>
+        </p:spPr>
+        <p:style>
+          <a:lnRef idx="1">
+            <a:schemeClr val="accent1"/>
+          </a:lnRef>
+          <a:fillRef idx="3">
+            <a:schemeClr val="accent1"/>
+          </a:fillRef>
+          <a:effectRef idx="2">
+            <a:schemeClr val="accent1"/>
+          </a:effectRef>
+          <a:fontRef idx="minor">
+            <a:schemeClr val="lt1"/>
+          </a:fontRef>
+        </p:style>
+        <p:txBody>
+          <a:bodyPr rtlCol="0" anchor="ctr"/>
+          <a:lstStyle/>
+          <a:p>
+            <a:pPr algn="ctr"/>
+          </a:p>
+        </p:txBody>
+      </p:sp>
+      <p:sp>
+        <p:nvSpPr>
+          <p:cNvPr id="10" name="TextBox 9"/>
+          <p:cNvSpPr txBox="1"/>
+          <p:nvPr/>
+        </p:nvSpPr>
+        <p:spPr>
+          <a:xfrm>
+            <a:off x="4023359" y="1645920"/>
+            <a:ext cx="2377440" cy="960120"/>
+          </a:xfrm>
+          <a:prstGeom prst="rect">
+            <a:avLst/>
+          </a:prstGeom>
+          <a:noFill/>
+        </p:spPr>
+        <p:txBody>
+          <a:bodyPr wrap="square" lIns="0" rIns="0" tIns="0" bIns="0" anchor="ctr">
+            <a:spAutoFit/>
+          </a:bodyPr>
+          <a:lstStyle/>
+          <a:p>
+            <a:pPr algn="l">
+              <a:spcAft>
+                <a:spcPts val="300"/>
+              </a:spcAft>
+            </a:pPr>
+            <a:r>
+              <a:rPr sz="1500" b="1" i="0">
+                <a:solidFill>
+                  <a:srgbClr val="39D353"/>
+                </a:solidFill>
+                <a:latin typeface="Arial"/>
+              </a:rPr>
+              <a:t>⬅ ➡ ⬆ ⬇ ARROWS</a:t>
+            </a:r>
+          </a:p>
+          <a:p>
+            <a:pPr algn="l"/>
+            <a:r>
+              <a:rPr sz="1050" b="0" i="0">
+                <a:solidFill>
+                  <a:srgbClr val="7E93B8"/>
+                </a:solidFill>
+                <a:latin typeface="Arial"/>
+              </a:rPr>
+              <a:t>steady rotation — line up an edge-on view</a:t>
+            </a:r>
+          </a:p>
+        </p:txBody>
+      </p:sp>
+      <p:sp>
+        <p:nvSpPr>
+          <p:cNvPr id="12" name="Rounded Rectangle 11"/>
+          <p:cNvSpPr/>
+          <p:nvPr/>
+        </p:nvSpPr>
+        <p:spPr>
+          <a:xfrm>
+            <a:off x="7040879" y="1645920"/>
+            <a:ext cx="2834640" cy="960120"/>
+          </a:xfrm>
+          <a:prstGeom prst="roundRect">
+            <a:avLst>
+              <a:gd name="adj" fmla="val 7000"/>
+            </a:avLst>
+          </a:prstGeom>
+          <a:solidFill>
+            <a:srgbClr val="0A1830"/>
+          </a:solidFill>
+          <a:ln w="12700">
+            <a:solidFill>
+              <a:srgbClr val="1E3A5F"/>
+            </a:solidFill>
+          </a:ln>
+          <a:effectLst/>
+        </p:spPr>
+        <p:style>
+          <a:lnRef idx="1">
+            <a:schemeClr val="accent1"/>
+          </a:lnRef>
+          <a:fillRef idx="3">
+            <a:schemeClr val="accent1"/>
+          </a:fillRef>
+          <a:effectRef idx="2">
+            <a:schemeClr val="accent1"/>
+          </a:effectRef>
+          <a:fontRef idx="minor">
+            <a:schemeClr val="lt1"/>
+          </a:fontRef>
+        </p:style>
+        <p:txBody>
+          <a:bodyPr rtlCol="0" anchor="ctr"/>
+          <a:lstStyle/>
+          <a:p>
+            <a:pPr algn="ctr"/>
+          </a:p>
+        </p:txBody>
+      </p:sp>
+      <p:sp>
+        <p:nvSpPr>
+          <p:cNvPr id="13" name="TextBox 12"/>
+          <p:cNvSpPr txBox="1"/>
+          <p:nvPr/>
+        </p:nvSpPr>
+        <p:spPr>
+          <a:xfrm>
+            <a:off x="7269479" y="1645920"/>
+            <a:ext cx="2377440" cy="960120"/>
+          </a:xfrm>
+          <a:prstGeom prst="rect">
+            <a:avLst/>
+          </a:prstGeom>
+          <a:noFill/>
+        </p:spPr>
+        <p:txBody>
+          <a:bodyPr wrap="square" lIns="0" rIns="0" tIns="0" bIns="0" anchor="ctr">
+            <a:spAutoFit/>
+          </a:bodyPr>
+          <a:lstStyle/>
+          <a:p>
+            <a:pPr algn="l">
+              <a:spcAft>
+                <a:spcPts val="300"/>
+              </a:spcAft>
+            </a:pPr>
+            <a:r>
+              <a:rPr sz="1500" b="1" i="0">
+                <a:solidFill>
+                  <a:srgbClr val="39D353"/>
+                </a:solidFill>
+                <a:latin typeface="Arial"/>
+              </a:rPr>
+              <a:t>, and .</a:t>
+            </a:r>
+          </a:p>
+          <a:p>
+            <a:pPr algn="l"/>
+            <a:r>
+              <a:rPr sz="1050" b="0" i="0">
+                <a:solidFill>
+                  <a:srgbClr val="7E93B8"/>
+                </a:solidFill>
+                <a:latin typeface="Arial"/>
+              </a:rPr>
+              <a:t>time flow: slower / faster</a:t>
+            </a:r>
+          </a:p>
+        </p:txBody>
+      </p:sp>
+      <p:sp>
+        <p:nvSpPr>
+          <p:cNvPr id="14" name="Oval 13"/>
+          <p:cNvSpPr/>
+          <p:nvPr/>
+        </p:nvSpPr>
+        <p:spPr>
+          <a:xfrm>
+            <a:off x="690371" y="3278124"/>
+            <a:ext cx="118872" cy="118872"/>
+          </a:xfrm>
+          <a:prstGeom prst="ellipse">
+            <a:avLst/>
+          </a:prstGeom>
+          <a:solidFill>
+            <a:srgbClr val="FFCF4D"/>
+          </a:solidFill>
+          <a:ln>
+            <a:noFill/>
+          </a:ln>
+          <a:effectLst/>
+        </p:spPr>
+        <p:style>
+          <a:lnRef idx="1">
+            <a:schemeClr val="accent1"/>
+          </a:lnRef>
+          <a:fillRef idx="3">
+            <a:schemeClr val="accent1"/>
+          </a:fillRef>
+          <a:effectRef idx="2">
+            <a:schemeClr val="accent1"/>
+          </a:effectRef>
+          <a:fontRef idx="minor">
+            <a:schemeClr val="lt1"/>
+          </a:fontRef>
+        </p:style>
+        <p:txBody>
+          <a:bodyPr rtlCol="0" anchor="ctr"/>
+          <a:lstStyle/>
+          <a:p>
+            <a:pPr algn="ctr"/>
+          </a:p>
+        </p:txBody>
+      </p:sp>
+      <p:sp>
+        <p:nvSpPr>
+          <p:cNvPr id="15" name="TextBox 14"/>
+          <p:cNvSpPr txBox="1"/>
+          <p:nvPr/>
+        </p:nvSpPr>
+        <p:spPr>
+          <a:xfrm>
+            <a:off x="1005840" y="3200400"/>
+            <a:ext cx="10607040" cy="685800"/>
+          </a:xfrm>
+          <a:prstGeom prst="rect">
+            <a:avLst/>
+          </a:prstGeom>
+          <a:noFill/>
+        </p:spPr>
+        <p:txBody>
+          <a:bodyPr wrap="square" lIns="0" rIns="0" tIns="0" bIns="0">
+            <a:spAutoFit/>
+          </a:bodyPr>
+          <a:lstStyle/>
+          <a:p>
+            <a:pPr algn="l"/>
+            <a:r>
+              <a:rPr sz="1350" b="0" i="0">
+                <a:solidFill>
+                  <a:srgbClr val="CFE3FF"/>
+                </a:solidFill>
+                <a:latin typeface="Arial"/>
+              </a:rPr>
+              <a:t>You are a camera flying around a fixed scene — dragging does not move the Earth, it moves you. R resets the view if you get lost.</a:t>
+            </a:r>
+          </a:p>
+        </p:txBody>
+      </p:sp>
+      <p:sp>
+        <p:nvSpPr>
+          <p:cNvPr id="16" name="Oval 15"/>
+          <p:cNvSpPr/>
+          <p:nvPr/>
+        </p:nvSpPr>
+        <p:spPr>
+          <a:xfrm>
+            <a:off x="690371" y="3991356"/>
+            <a:ext cx="118872" cy="118872"/>
+          </a:xfrm>
+          <a:prstGeom prst="ellipse">
+            <a:avLst/>
+          </a:prstGeom>
+          <a:solidFill>
+            <a:srgbClr val="FFCF4D"/>
+          </a:solidFill>
+          <a:ln>
+            <a:noFill/>
+          </a:ln>
+          <a:effectLst/>
+        </p:spPr>
+        <p:style>
+          <a:lnRef idx="1">
+            <a:schemeClr val="accent1"/>
+          </a:lnRef>
+          <a:fillRef idx="3">
+            <a:schemeClr val="accent1"/>
+          </a:fillRef>
+          <a:effectRef idx="2">
+            <a:schemeClr val="accent1"/>
+          </a:effectRef>
+          <a:fontRef idx="minor">
+            <a:schemeClr val="lt1"/>
+          </a:fontRef>
+        </p:style>
+        <p:txBody>
+          <a:bodyPr rtlCol="0" anchor="ctr"/>
+          <a:lstStyle/>
+          <a:p>
+            <a:pPr algn="ctr"/>
+          </a:p>
+        </p:txBody>
+      </p:sp>
+      <p:sp>
+        <p:nvSpPr>
+          <p:cNvPr id="17" name="TextBox 16"/>
+          <p:cNvSpPr txBox="1"/>
+          <p:nvPr/>
+        </p:nvSpPr>
+        <p:spPr>
+          <a:xfrm>
+            <a:off x="1005840" y="3913632"/>
+            <a:ext cx="10607040" cy="685800"/>
+          </a:xfrm>
+          <a:prstGeom prst="rect">
+            <a:avLst/>
+          </a:prstGeom>
+          <a:noFill/>
+        </p:spPr>
+        <p:txBody>
+          <a:bodyPr wrap="square" lIns="0" rIns="0" tIns="0" bIns="0">
+            <a:spAutoFit/>
+          </a:bodyPr>
+          <a:lstStyle/>
+          <a:p>
+            <a:pPr algn="l"/>
+            <a:r>
+              <a:rPr sz="1350" b="0" i="0">
+                <a:solidFill>
+                  <a:srgbClr val="CFE3FF"/>
+                </a:solidFill>
+                <a:latin typeface="Arial"/>
+              </a:rPr>
+              <a:t>Use the ARROW KEYS to tip the view until an orbit is exactly edge-on: that is how you judge its tilt (inclination) by eye.</a:t>
+            </a:r>
+          </a:p>
+        </p:txBody>
+      </p:sp>
+      <p:sp>
+        <p:nvSpPr>
+          <p:cNvPr id="18" name="Oval 17"/>
+          <p:cNvSpPr/>
+          <p:nvPr/>
+        </p:nvSpPr>
+        <p:spPr>
+          <a:xfrm>
+            <a:off x="690371" y="4704588"/>
+            <a:ext cx="118872" cy="118872"/>
+          </a:xfrm>
+          <a:prstGeom prst="ellipse">
+            <a:avLst/>
+          </a:prstGeom>
+          <a:solidFill>
+            <a:srgbClr val="FFCF4D"/>
+          </a:solidFill>
+          <a:ln>
+            <a:noFill/>
+          </a:ln>
+          <a:effectLst/>
+        </p:spPr>
+        <p:style>
+          <a:lnRef idx="1">
+            <a:schemeClr val="accent1"/>
+          </a:lnRef>
+          <a:fillRef idx="3">
+            <a:schemeClr val="accent1"/>
+          </a:fillRef>
+          <a:effectRef idx="2">
+            <a:schemeClr val="accent1"/>
+          </a:effectRef>
+          <a:fontRef idx="minor">
+            <a:schemeClr val="lt1"/>
+          </a:fontRef>
+        </p:style>
+        <p:txBody>
+          <a:bodyPr rtlCol="0" anchor="ctr"/>
+          <a:lstStyle/>
+          <a:p>
+            <a:pPr algn="ctr"/>
+          </a:p>
+        </p:txBody>
+      </p:sp>
+      <p:sp>
+        <p:nvSpPr>
+          <p:cNvPr id="19" name="TextBox 18"/>
+          <p:cNvSpPr txBox="1"/>
+          <p:nvPr/>
+        </p:nvSpPr>
+        <p:spPr>
+          <a:xfrm>
+            <a:off x="1005840" y="4626864"/>
+            <a:ext cx="10607040" cy="685800"/>
+          </a:xfrm>
+          <a:prstGeom prst="rect">
+            <a:avLst/>
+          </a:prstGeom>
+          <a:noFill/>
+        </p:spPr>
+        <p:txBody>
+          <a:bodyPr wrap="square" lIns="0" rIns="0" tIns="0" bIns="0">
+            <a:spAutoFit/>
+          </a:bodyPr>
+          <a:lstStyle/>
+          <a:p>
+            <a:pPr algn="l"/>
+            <a:r>
+              <a:rPr sz="1350" b="0" i="0">
+                <a:solidFill>
+                  <a:srgbClr val="CFE3FF"/>
+                </a:solidFill>
+                <a:latin typeface="Arial"/>
+              </a:rPr>
+              <a:t>A LEO lap takes ~90 minutes and GEO takes a day, so , and . are not a gimmick — without time warp, most of this course is too slow to watch.</a:t>
+            </a:r>
+          </a:p>
+        </p:txBody>
+      </p:sp>
+      <p:sp>
+        <p:nvSpPr>
+          <p:cNvPr id="20" name="Oval 19"/>
+          <p:cNvSpPr/>
+          <p:nvPr/>
+        </p:nvSpPr>
+        <p:spPr>
+          <a:xfrm>
+            <a:off x="690371" y="5417820"/>
+            <a:ext cx="118872" cy="118872"/>
+          </a:xfrm>
+          <a:prstGeom prst="ellipse">
+            <a:avLst/>
+          </a:prstGeom>
+          <a:solidFill>
+            <a:srgbClr val="FFCF4D"/>
+          </a:solidFill>
+          <a:ln>
+            <a:noFill/>
+          </a:ln>
+          <a:effectLst/>
+        </p:spPr>
+        <p:style>
+          <a:lnRef idx="1">
+            <a:schemeClr val="accent1"/>
+          </a:lnRef>
+          <a:fillRef idx="3">
+            <a:schemeClr val="accent1"/>
+          </a:fillRef>
+          <a:effectRef idx="2">
+            <a:schemeClr val="accent1"/>
+          </a:effectRef>
+          <a:fontRef idx="minor">
+            <a:schemeClr val="lt1"/>
+          </a:fontRef>
+        </p:style>
+        <p:txBody>
+          <a:bodyPr rtlCol="0" anchor="ctr"/>
+          <a:lstStyle/>
+          <a:p>
+            <a:pPr algn="ctr"/>
+          </a:p>
+        </p:txBody>
+      </p:sp>
+      <p:sp>
+        <p:nvSpPr>
+          <p:cNvPr id="21" name="TextBox 20"/>
+          <p:cNvSpPr txBox="1"/>
+          <p:nvPr/>
+        </p:nvSpPr>
+        <p:spPr>
+          <a:xfrm>
+            <a:off x="1005840" y="5340096"/>
+            <a:ext cx="10607040" cy="685800"/>
+          </a:xfrm>
+          <a:prstGeom prst="rect">
+            <a:avLst/>
+          </a:prstGeom>
+          <a:noFill/>
+        </p:spPr>
+        <p:txBody>
+          <a:bodyPr wrap="square" lIns="0" rIns="0" tIns="0" bIns="0">
+            <a:spAutoFit/>
+          </a:bodyPr>
+          <a:lstStyle/>
+          <a:p>
+            <a:pPr algn="l"/>
+            <a:r>
+              <a:rPr sz="1350" b="0" i="0">
+                <a:solidFill>
+                  <a:srgbClr val="CFE3FF"/>
+                </a:solidFill>
+                <a:latin typeface="Arial"/>
+              </a:rPr>
+              <a:t>The left panel is the control board: tick boxes switch real constellations on, the three sliders set up your own object, and ◇ INJECT OBJECT launches it.</a:t>
             </a:r>
           </a:p>
         </p:txBody>

</xml_diff>